<commit_message>
S01 v5: fondos sin repetir en dias seguidos
</commit_message>
<xml_diff>
--- a/Domingo-14/S01_Domingo-14_3_Story_Caja-de-preguntas_9x16.pptx
+++ b/Domingo-14/S01_Domingo-14_3_Story_Caja-de-preguntas_9x16.pptx
@@ -3098,7 +3098,7 @@
       <p:grpSpPr/>
       <p:pic>
         <p:nvPicPr>
-          <p:cNvPr id="2" name="Picture 1" descr="oficina.png"/>
+          <p:cNvPr id="2" name="Picture 1" descr="textura.png"/>
           <p:cNvPicPr>
             <a:picLocks noChangeAspect="1"/>
           </p:cNvPicPr>
@@ -3112,8 +3112,8 @@
         </p:blipFill>
         <p:spPr>
           <a:xfrm>
-            <a:off x="-1371600" y="0"/>
-            <a:ext cx="10972800" cy="14630400"/>
+            <a:off x="-1347216" y="0"/>
+            <a:ext cx="10924032" cy="14630400"/>
           </a:xfrm>
           <a:prstGeom prst="rect">
             <a:avLst/>

</xml_diff>